<commit_message>
feat: add initial slide deck and demo for ProofPick project
- Created package.json for Slidev setup with necessary scripts and dependencies.
- Added demo.html showcasing the ProofPick product selection process with interactive steps.
- Introduced slides.md containing the presentation content and structure for the ProofPick concept.
</commit_message>
<xml_diff>
--- a/submission/zenjyocon_entry_sheet_2026.pptx
+++ b/submission/zenjyocon_entry_sheet_2026.pptx
@@ -8926,7 +8926,7 @@
                           </a:solidFill>
                           <a:latin typeface="Hiragino Sans"/>
                         </a:rPr>
-                        <a:t>米川 明希、吉田 創也、はいまい、棚橋 弘（暗号回路設計リード）</a:t>
+                        <a:t>米川 明希、吉田 創也、今井、棚橋 弘（暗号回路設計リード）</a:t>
                       </a:r>
                       <a:endParaRPr sz="1400" u="none" cap="none" strike="noStrike">
                         <a:solidFill>
@@ -9276,7 +9276,7 @@
               </a:rPr>
               <a:t>1. 暗号プログラムでのグループ議論: AIエージェントの運用実績(task, trace)を機密非開示で損保に証明する保険モデルとvFHE(ZK+FHE)を設計
 2. 学会論文調査(CSS2026): プロンプトインジェクション防御(ASIDE+ICA)、Random Forest分岐器トリアージ、VLA動的チャンク制御、証跡Locatorの決定論的Lint、指定確認者墨塗署名(DCSS)の最新手法を分析
-3. チーム役割分担とエンジニア実装: 暗号回路設計を核（7割牽引）とし、はいまいくんがロボット制御とMPCエンドポイント、米川くん・吉田くんが分岐器トリアージとPIIマスクWeb基盤を実装。プロトタイプで呼出23%削減・自動署名670ms・DCSS検証0.58msを確認</a:t>
+3. チーム役割分担とエンジニア実装: 暗号回路設計を核（7割牽引）とし、今井くんがロボット制御とMPCエンドポイント、米川くん・吉田くんが分岐器トリアージとPIIマスクWeb基盤を実装。CSS2026で有効性が報告された手法（分岐器トリアージ・OP-TEE署名・DCSS等）を選定し、モック実装に着手</a:t>
             </a:r>
           </a:p>
           <a:p>
@@ -10655,10 +10655,10 @@
                 <a:latin typeface="Hiragino Sans"/>
               </a:rPr>
               <a:t>1. 注文受付・マスク: 注文や画像から個人情報をエッジで即時マスク化
-2. 分岐器トリアージ: 定型注文はLLMを介さず高速処理（呼出23%削減）
+2. 分岐器トリアージ: 定型注文はLLMを介さず高速処理
 3. 防御推論: ASIDE+ICAで店内偽POPを遮断、動的チャンク制御で暴走抑制
 4. Lookup検討証明: どの正規商品テーブルと比較検討したかをZKで証明
-5. モデル外安全強制: TEE内のCNEIゲートで要求超過操作を100%遮断
+5. モデル外安全強制: TEE内のCNEIゲートで要求超過操作を遮断
 6. 経済・保険監査: ZK無開示査定と有事の指定確認者墨塗署名(DCSS)で監査</a:t>
             </a:r>
             <a:endParaRPr b="0" i="0" sz="1200" u="none" cap="none" strike="noStrike">
@@ -12030,9 +12030,9 @@
               </a:rPr>
               <a:t>[入力] スマホ注文・店内カメラ映像・棚マスタデータ
   ↓
-[処理① 前段] PII事前マスク ＋ 分岐器トリアージで定型注文を高速バイパス（呼出23%削減）
-[処理② 推論] ASIDE+ICAで店内POPの騙し命令を無力化 ＋ VLA動的チャンクで暴走を1msで抑止
-[処理③ 証明] 「何を比較検討したか」をZK Lookupで数学的に証明 ＋ TEE内CNEIで要求超過を100%遮断
+[処理① 前段] PII事前マスク ＋ 分岐器トリアージで定型注文を高速バイパス
+[処理② 推論] ASIDE+ICAで店内POPの騙し命令を無力化 ＋ VLA動的チャンクで暴走を即時抑止
+[処理③ 証明] 「何を比較検討したか」をZK Lookupで数学的に証明 ＋ TEE内CNEIで要求超過を遮断
   ↓
 [出力] ロボットの物理ピックアップ実行 ＋ ブロックチェーンで報酬自動決済 ＋ お客様・損保へ監査証明提示</a:t>
             </a:r>
@@ -12318,17 +12318,17 @@
               <a:t>[1. 入力層] 注文テキスト・店内カメラ・棚札 ➔ [軽量PII事前マスク(Regex+ローカルLLM)] ＆ [ハードウェア署名]
   ↓
 [2. 分岐器＆標準モデル層]
-  ├─ (A) 定型・低リスクピッキング ➔ [分岐器(RF/LR Router) + Density Gate] ➔ 直接商品Lookupへ直行(23%削減)
+  ├─ (A) 定型・低リスクピッキング ➔ [分岐器(RF/LR Router) + Density Gate] ➔ 直接商品Lookupへ直行
   └─ (B) 非定型・複合注文 ➔ [分散LLM (ASIDE+ICA動的ゲートでPOP攻撃無力化)] ＋ [VLA動的Action Chunking]
   ↓
 [3. 商品選択Lookup証明＆TEE安全強制層]
-  ・[商品マスタLUT参照証明 (ZK Lookup)] ＋ [三層知識バンドル(Claim-Artifact-Locator) &amp; 決定論的Lint(違反0%)]
-  ・[OP-TEE隔離 &amp; CNEIゲート]：操作上限 Level(a) ≤ τ をモデル外で強制、ポリシー適合時のみ把持実行＆自動署名(670ms)
+  ・[商品マスタLUT参照証明 (ZK Lookup)] ＋ [三層知識バンドル(Claim-Artifact-Locator) &amp; 決定論的Lint]
+  ・[OP-TEE隔離 &amp; CNEIゲート]：操作上限 Level(a) ≤ τ をモデル外で強制、ポリシー適合時のみ把持実行＆自動署名
   ↓
 [4. 分散チェーン＆保険監査出力（右図参照）]
   ・[コンソーシアムチェーン] 部分グラフ合議で企業秘密を守りつつロボットへ報酬トークンを自動決済
   ・[平時：ZK/vFHE無開示査定] 顧客データ・モデル重みxを秘匿したまま約款合致πを損保・お客様へ証明
-  ・[有事：指定確認者墨塗署名(DCSS) × 3-of-5閾値開示] 事故発生時のみ裁判所・第三者機関が墨塗り箇所を0.58msで検証</a:t>
+  ・[有事：指定確認者墨塗署名(DCSS) × 3-of-5閾値開示] 事故発生時のみ裁判所・第三者機関が墨塗り箇所を高速に検証</a:t>
             </a:r>
           </a:p>
         </p:txBody>
@@ -12580,17 +12580,17 @@
    - スマホから注文データを受信、店内カメラが棚画像を取得
    - 定型個人情報は正規表現で即座にマスク、曖昧な箇所のみローカルLLMで補正
 2. [分岐器トリアージによるルーティング (米川・吉田担当)]
-   - 定型的な商品指定の場合、LLMを呼ばずに直接Lookup処理へジャンプ（呼出23%削減）
+   - 定型的な商品指定の場合、LLMを呼ばずに直接Lookup処理へジャンプ
    - 複雑な注文のみ、ASIDE+ICA防御が有効化された分散LLMへ送信
-3. [推論と物理制御の安定化（繰り返しループ：はいまい担当）]
+3. [推論と物理制御の安定化（繰り返しループ：今井担当）]
    - 店内POPの悪意ある命令を動的ゲートで遮断しながら商品候補を推論
    - ロボット移動時、未実行行動列との割引累積不一致度を毎ステップ監視。異常検知時は実行長を1に短縮し減速
 4. [商品Lookup検討と証跡記録（暗号回路設計担当）]
    - 店舗の正規商品テーブル(LUT)から候補商品を比較検討（アレルギー・価格・鮮度）
-   - 根拠となった棚画像座標(image_bbox)を三層バンドルに記録し、決定論的Lintで不整合を検査（違反0%強制）
+   - 根拠となった棚画像座標(image_bbox)を三層バンドルに記録し、決定論的Lintで不整合を検査（整合性を強制）
 5. [TEEモデル外強制と署名判断（条件分岐）]
    - CNEIゲートが操作上限を確認。不正な要求超過操作はfail-closedで即座に遮断
-   - ポリシー適合時はOP-TEE内で自動署名(670ms)、予算超過時はユーザー確認へ分岐、形式不正は拒否
+   - ポリシー適合時はOP-TEE内で自動署名、予算超過時はユーザー確認へ分岐、形式不正は拒否
 6. [ピックアップ実行・報酬決済・保険監査]
    - 商品をピッキングし、ZK Lookup証明とProgress Receiptを発行
    - コンソーシアムチェーンでロボットへ報酬を支払い、平時はZK無開示査定、有事はDCSSで裁判所が開示検証</a:t>
@@ -12822,7 +12822,7 @@
    - レイヤごとの絞り込み、各ノードの数理仕様やCSS2026着想論文の確認、仕様書のMarkdown/JSON出力が可能
 2. [商品Lookup証明＆インジェクション遮断モック画面]
    - 店内の偽POPを検知してCNEIゲートが赤枠で遮断するデモ画面
-   - 「候補A(小麦あり)と候補B(米粉)を比較しBを選択した」ZK Proofのリアルタイム生成・検証結果（0.6秒）を表示
+   - 「候補A(小麦あり)と候補B(米粉)を比較しBを選択した」ZK Proofのリアルタイム生成・検証結果を表示
 3. [3者切り替え監査ビュー（平時・有事）]
    - お客様・損保ビュー: モデル知財と個人情報が完全に墨塗り（🔒）されたまま「約款適合」を証明
    - 裁判所ビュー: 事故発生時に3-of-5秘密分散が揃った場合のみ指定確認者が元ログを復号検証できる画面</a:t>
@@ -13077,7 +13077,7 @@
    - 高度なゼロ知識証明(ZKP)や完全準同型暗号(vFHE)の数式を裏側で自動処理
    - 顧客スマホ画面には「✓ アレルゲン基準クリア」「✓ 個人情報マスク済」と直感的な緑色バッジと棚写真の枠線だけを表示
 2. 現場の負担ゼロ（OP-TEEによる3分岐オートメーション）:
-   - 全ての操作で人間が確認ボタンを押す必要をなくし、通常ピッキングは100%自動署名（平均670ms）
+   - 全ての操作で人間が確認ボタンを押す必要をなくし、通常ピッキングは自動署名
    - 予算超過や品切れ代替品の提案時のみスマホへ通知し、不正な命令は自動遮断
 3. 視覚的で分かりやすいフィードバック:
    - 統合ホワイトボード画面で、信号機カラー（緑＝安全、赤＝遮断、黄＝確認）を用いてシステムの稼働状況を直感的に把握可能

</xml_diff>

<commit_message>
chore: remove personal names from repo (keep in submission only)
- anonymize team names in README, md docs, unko, STRATEGY
- drop 担当 labels from issues and docs
- update entry sheet roster (今井・米川 removed; 吉田=API)

Generated with [Devin](https://devin.ai)

Co-Authored-By: Devin <158243242+devin-ai-integration[bot]@users.noreply.github.com>
</commit_message>
<xml_diff>
--- a/submission/zenjyocon_entry_sheet_2026.pptx
+++ b/submission/zenjyocon_entry_sheet_2026.pptx
@@ -8926,7 +8926,7 @@
                           </a:solidFill>
                           <a:latin typeface="Hiragino Sans"/>
                         </a:rPr>
-                        <a:t>米川 明希、吉田 紬、今井</a:t>
+                        <a:t>吉田 紬</a:t>
                       </a:r>
                       <a:endParaRPr sz="1400" u="none" cap="none" strike="noStrike">
                         <a:solidFill>
@@ -12579,10 +12579,10 @@
               <a:t>1. [注文受付・PII事前マスク]
    - スマホから注文データを受信、店内カメラが棚画像を取得
    - 定型個人情報は正規表現で即座にマスク、曖昧な箇所のみローカルLLMで補正
-2. [分岐器トリアージによるルーティング (米川・吉田担当)]
+2. [分岐器トリアージによるルーティング (Web担当)]
    - 定型的な商品指定の場合、LLMを呼ばずに直接Lookup処理へジャンプ
    - 複雑な注文のみ、ASIDE+ICA防御が有効化された分散LLMへ送信
-3. [推論と物理制御の安定化（繰り返しループ：今井担当）]
+3. [推論と物理制御の安定化（繰り返しループ：API担当）]
    - 店内POPの悪意ある命令を動的ゲートで遮断しながら商品候補を推論
    - ロボット移動時、未実行行動列との割引累積不一致度を毎ステップ監視。異常検知時は実行長を1に短縮し減速
 4. [商品Lookup検討と証跡記録（暗号回路設計担当）]

</xml_diff>